<commit_message>
Blockchain Game Jam deck: credit the source talk (title slide) and add Watch the talk + QR (closing slide); add deck source
</commit_message>
<xml_diff>
--- a/docs/blockchain-game-jam/blockchain-game-jam.pptx
+++ b/docs/blockchain-game-jam/blockchain-game-jam.pptx
@@ -548,6 +548,11 @@
           <a:p/>
           <a:p>
             <a:r>
+              <a:t>The 'Based on' line on the slide credits the source video; the last slide repeats it with a QR code.</a:t>
+            </a:r>
+          </a:p>
+          <a:p>
+            <a:r>
               <a:t>Source for the whole deck: "Moving Beyond Centralized Gaming using the Nexa Blockchain: with Steven van den Meiracker", Nexa YouTube channel, uploaded 10 Jul 2026 (https://www.youtube.com/watch?v=NHAPE0JRhCM). Webinar hosted by Danielle at EvolvH3R. The card "Defense Boost 100" appears in the demo at 00:29:25.</a:t>
             </a:r>
           </a:p>
@@ -996,6 +1001,11 @@
             </a:r>
           </a:p>
           <a:p/>
+          <a:p>
+            <a:r>
+              <a:t>- Watch the talk (QR code on the slide): "Moving Beyond Centralized Gaming using the Nexa Blockchain - with Steven van den Meiracker", Nexa on YouTube, 2026 - https://www.youtube.com/watch?v=NHAPE0JRhCM. Point people to the Nexa Warriors demo from 00:23:14.</a:t>
+            </a:r>
+          </a:p>
           <a:p>
             <a:r>
               <a:t>- Close the loop from slide 1: "Who owns this card?" - the player. And at the jam, students build the next game around it.</a:t>
@@ -5493,6 +5503,70 @@
           </a:p>
         </p:txBody>
       </p:sp>
+      <p:sp>
+        <p:nvSpPr>
+          <p:cNvPr id="19" name="TextBox 18"/>
+          <p:cNvSpPr txBox="1"/>
+          <p:nvPr/>
+        </p:nvSpPr>
+        <p:spPr>
+          <a:xfrm>
+            <a:off x="5394960" y="5669280"/>
+            <a:ext cx="6263640" cy="548640"/>
+          </a:xfrm>
+          <a:prstGeom prst="rect">
+            <a:avLst/>
+          </a:prstGeom>
+          <a:noFill/>
+        </p:spPr>
+        <p:txBody>
+          <a:bodyPr wrap="square" lIns="45720" rIns="45720" tIns="27432" bIns="27432" anchor="t">
+            <a:spAutoFit/>
+          </a:bodyPr>
+          <a:lstStyle/>
+          <a:p>
+            <a:pPr algn="r">
+              <a:lnSpc>
+                <a:spcPct val="110000"/>
+              </a:lnSpc>
+            </a:pPr>
+            <a:r>
+              <a:rPr sz="1100" b="1" i="0">
+                <a:solidFill>
+                  <a:srgbClr val="FFD23F"/>
+                </a:solidFill>
+                <a:latin typeface="Inter"/>
+              </a:rPr>
+              <a:t>Based on: </a:t>
+            </a:r>
+            <a:r>
+              <a:rPr sz="1100" b="0" i="1">
+                <a:solidFill>
+                  <a:srgbClr val="9AA4B5"/>
+                </a:solidFill>
+                <a:latin typeface="Inter"/>
+              </a:rPr>
+              <a:t>“Moving Beyond Centralized Gaming using the Nexa Blockchain”</a:t>
+            </a:r>
+          </a:p>
+          <a:p>
+            <a:pPr algn="r">
+              <a:lnSpc>
+                <a:spcPct val="110000"/>
+              </a:lnSpc>
+            </a:pPr>
+            <a:r>
+              <a:rPr sz="1100" b="0" i="0">
+                <a:solidFill>
+                  <a:srgbClr val="9AA4B5"/>
+                </a:solidFill>
+                <a:latin typeface="Inter"/>
+              </a:rPr>
+              <a:t>with Steven van den Meiracker  ·  Nexa on YouTube, 2026</a:t>
+            </a:r>
+          </a:p>
+        </p:txBody>
+      </p:sp>
     </p:spTree>
   </p:cSld>
   <p:clrMapOvr>
@@ -13318,8 +13392,8 @@
         </p:nvSpPr>
         <p:spPr>
           <a:xfrm>
-            <a:off x="1188720" y="1463040"/>
-            <a:ext cx="2331720" cy="3291839"/>
+            <a:off x="1417320" y="1188720"/>
+            <a:ext cx="1865376" cy="2633472"/>
           </a:xfrm>
           <a:prstGeom prst="roundRect">
             <a:avLst>
@@ -13329,7 +13403,7 @@
           <a:solidFill>
             <a:srgbClr val="202633"/>
           </a:solidFill>
-          <a:ln w="47625">
+          <a:ln w="38100">
             <a:solidFill>
               <a:srgbClr val="2EC48A"/>
             </a:solidFill>
@@ -13366,8 +13440,8 @@
         </p:nvSpPr>
         <p:spPr>
           <a:xfrm>
-            <a:off x="1188720" y="1600200"/>
-            <a:ext cx="2331720" cy="411479"/>
+            <a:off x="1417320" y="1298448"/>
+            <a:ext cx="1865376" cy="329184"/>
           </a:xfrm>
           <a:prstGeom prst="rect">
             <a:avLst/>
@@ -13386,7 +13460,7 @@
               </a:lnSpc>
             </a:pPr>
             <a:r>
-              <a:rPr sz="1500" b="1" i="0">
+              <a:rPr sz="1200" b="1" i="0">
                 <a:solidFill>
                   <a:srgbClr val="2EC48A"/>
                 </a:solidFill>
@@ -13405,8 +13479,8 @@
         </p:nvSpPr>
         <p:spPr>
           <a:xfrm>
-            <a:off x="1778508" y="2121408"/>
-            <a:ext cx="1152144" cy="1303019"/>
+            <a:off x="1889150" y="1715414"/>
+            <a:ext cx="921715" cy="1042415"/>
           </a:xfrm>
           <a:prstGeom prst="plaque">
             <a:avLst/>
@@ -13449,8 +13523,8 @@
         </p:nvSpPr>
         <p:spPr>
           <a:xfrm>
-            <a:off x="1234440" y="3520440"/>
-            <a:ext cx="2240279" cy="480059"/>
+            <a:off x="1463040" y="2834639"/>
+            <a:ext cx="1773936" cy="384048"/>
           </a:xfrm>
           <a:prstGeom prst="rect">
             <a:avLst/>
@@ -13469,7 +13543,7 @@
               </a:lnSpc>
             </a:pPr>
             <a:r>
-              <a:rPr sz="1900" b="1" i="0">
+              <a:rPr sz="1500" b="1" i="0">
                 <a:solidFill>
                   <a:srgbClr val="F2F4F8"/>
                 </a:solidFill>
@@ -13488,8 +13562,8 @@
         </p:nvSpPr>
         <p:spPr>
           <a:xfrm>
-            <a:off x="1234440" y="3931920"/>
-            <a:ext cx="2240279" cy="480059"/>
+            <a:off x="1463040" y="3163824"/>
+            <a:ext cx="1773936" cy="384048"/>
           </a:xfrm>
           <a:prstGeom prst="rect">
             <a:avLst/>
@@ -13508,7 +13582,7 @@
               </a:lnSpc>
             </a:pPr>
             <a:r>
-              <a:rPr sz="1900" b="1" i="0">
+              <a:rPr sz="1500" b="1" i="0">
                 <a:solidFill>
                   <a:srgbClr val="F2F4F8"/>
                 </a:solidFill>
@@ -13519,16 +13593,40 @@
           </a:p>
         </p:txBody>
       </p:sp>
-      <p:sp>
-        <p:nvSpPr>
-          <p:cNvPr id="9" name="TextBox 8"/>
+      <p:pic>
+        <p:nvPicPr>
+          <p:cNvPr id="9" name="Picture 8" descr="qr-talk.png"/>
+          <p:cNvPicPr>
+            <a:picLocks noChangeAspect="1"/>
+          </p:cNvPicPr>
+          <p:nvPr/>
+        </p:nvPicPr>
+        <p:blipFill>
+          <a:blip r:embed="rId2"/>
+          <a:stretch>
+            <a:fillRect/>
+          </a:stretch>
+        </p:blipFill>
+        <p:spPr>
+          <a:xfrm>
+            <a:off x="1005840" y="4206240"/>
+            <a:ext cx="1188720" cy="1188720"/>
+          </a:xfrm>
+          <a:prstGeom prst="rect">
+            <a:avLst/>
+          </a:prstGeom>
+        </p:spPr>
+      </p:pic>
+      <p:sp>
+        <p:nvSpPr>
+          <p:cNvPr id="10" name="TextBox 9"/>
           <p:cNvSpPr txBox="1"/>
           <p:nvPr/>
         </p:nvSpPr>
         <p:spPr>
           <a:xfrm>
-            <a:off x="4572000" y="1554480"/>
-            <a:ext cx="6949440" cy="457200"/>
+            <a:off x="2331720" y="4206240"/>
+            <a:ext cx="2148840" cy="365760"/>
           </a:xfrm>
           <a:prstGeom prst="rect">
             <a:avLst/>
@@ -13547,27 +13645,27 @@
               </a:lnSpc>
             </a:pPr>
             <a:r>
-              <a:rPr sz="1800" b="1" i="0">
+              <a:rPr sz="1300" b="1" i="0">
                 <a:solidFill>
                   <a:srgbClr val="FFD23F"/>
                 </a:solidFill>
                 <a:latin typeface="Inter"/>
               </a:rPr>
-              <a:t>SO, WHO OWNS THIS CARD?</a:t>
-            </a:r>
-          </a:p>
-        </p:txBody>
-      </p:sp>
-      <p:sp>
-        <p:nvSpPr>
-          <p:cNvPr id="10" name="TextBox 9"/>
+              <a:t>WATCH THE TALK</a:t>
+            </a:r>
+          </a:p>
+        </p:txBody>
+      </p:sp>
+      <p:sp>
+        <p:nvSpPr>
+          <p:cNvPr id="11" name="TextBox 10"/>
           <p:cNvSpPr txBox="1"/>
           <p:nvPr/>
         </p:nvSpPr>
         <p:spPr>
           <a:xfrm>
-            <a:off x="4572000" y="2011680"/>
-            <a:ext cx="6949440" cy="1645920"/>
+            <a:off x="2331720" y="4526280"/>
+            <a:ext cx="2148840" cy="914400"/>
           </a:xfrm>
           <a:prstGeom prst="rect">
             <a:avLst/>
@@ -13586,13 +13684,13 @@
               </a:lnSpc>
             </a:pPr>
             <a:r>
-              <a:rPr sz="3800" b="1" i="0">
+              <a:rPr sz="1000" b="0" i="0">
                 <a:solidFill>
                   <a:srgbClr val="F2F4F8"/>
                 </a:solidFill>
                 <a:latin typeface="Inter"/>
               </a:rPr>
-              <a:t>The player.</a:t>
+              <a:t>“Moving Beyond Centralized Gaming using the Nexa Blockchain”</a:t>
             </a:r>
           </a:p>
           <a:p>
@@ -13602,12 +13700,161 @@
               </a:lnSpc>
             </a:pPr>
             <a:r>
+              <a:rPr sz="1000" b="0" i="0">
+                <a:solidFill>
+                  <a:srgbClr val="F2F4F8"/>
+                </a:solidFill>
+                <a:latin typeface="Inter"/>
+              </a:rPr>
+              <a:t>Steven van den Meiracker</a:t>
+            </a:r>
+          </a:p>
+          <a:p>
+            <a:pPr algn="l">
+              <a:lnSpc>
+                <a:spcPct val="105000"/>
+              </a:lnSpc>
+            </a:pPr>
+            <a:r>
+              <a:rPr sz="1000" b="0" i="0">
+                <a:solidFill>
+                  <a:srgbClr val="F2F4F8"/>
+                </a:solidFill>
+                <a:latin typeface="Inter"/>
+              </a:rPr>
+              <a:t>Nexa on YouTube, 2026</a:t>
+            </a:r>
+          </a:p>
+        </p:txBody>
+      </p:sp>
+      <p:sp>
+        <p:nvSpPr>
+          <p:cNvPr id="12" name="TextBox 11"/>
+          <p:cNvSpPr txBox="1"/>
+          <p:nvPr/>
+        </p:nvSpPr>
+        <p:spPr>
+          <a:xfrm>
+            <a:off x="960120" y="5486400"/>
+            <a:ext cx="3566160" cy="320040"/>
+          </a:xfrm>
+          <a:prstGeom prst="rect">
+            <a:avLst/>
+          </a:prstGeom>
+          <a:noFill/>
+        </p:spPr>
+        <p:txBody>
+          <a:bodyPr wrap="square" lIns="45720" rIns="45720" tIns="27432" bIns="27432" anchor="t">
+            <a:spAutoFit/>
+          </a:bodyPr>
+          <a:lstStyle/>
+          <a:p>
+            <a:pPr algn="l">
+              <a:lnSpc>
+                <a:spcPct val="110000"/>
+              </a:lnSpc>
+            </a:pPr>
+            <a:r>
+              <a:rPr sz="1100" b="0" i="0">
+                <a:solidFill>
+                  <a:srgbClr val="9AA4B5"/>
+                </a:solidFill>
+                <a:latin typeface="Inter"/>
+              </a:rPr>
+              <a:t>youtube.com/watch?v=NHAPE0JRhCM</a:t>
+            </a:r>
+          </a:p>
+        </p:txBody>
+      </p:sp>
+      <p:sp>
+        <p:nvSpPr>
+          <p:cNvPr id="13" name="TextBox 12"/>
+          <p:cNvSpPr txBox="1"/>
+          <p:nvPr/>
+        </p:nvSpPr>
+        <p:spPr>
+          <a:xfrm>
+            <a:off x="4572000" y="1554480"/>
+            <a:ext cx="6949440" cy="457200"/>
+          </a:xfrm>
+          <a:prstGeom prst="rect">
+            <a:avLst/>
+          </a:prstGeom>
+          <a:noFill/>
+        </p:spPr>
+        <p:txBody>
+          <a:bodyPr wrap="square" lIns="45720" rIns="45720" tIns="27432" bIns="27432" anchor="t">
+            <a:spAutoFit/>
+          </a:bodyPr>
+          <a:lstStyle/>
+          <a:p>
+            <a:pPr algn="l">
+              <a:lnSpc>
+                <a:spcPct val="110000"/>
+              </a:lnSpc>
+            </a:pPr>
+            <a:r>
+              <a:rPr sz="1800" b="1" i="0">
+                <a:solidFill>
+                  <a:srgbClr val="FFD23F"/>
+                </a:solidFill>
+                <a:latin typeface="Inter"/>
+              </a:rPr>
+              <a:t>SO, WHO OWNS THIS CARD?</a:t>
+            </a:r>
+          </a:p>
+        </p:txBody>
+      </p:sp>
+      <p:sp>
+        <p:nvSpPr>
+          <p:cNvPr id="14" name="TextBox 13"/>
+          <p:cNvSpPr txBox="1"/>
+          <p:nvPr/>
+        </p:nvSpPr>
+        <p:spPr>
+          <a:xfrm>
+            <a:off x="4572000" y="2011680"/>
+            <a:ext cx="6949440" cy="1645920"/>
+          </a:xfrm>
+          <a:prstGeom prst="rect">
+            <a:avLst/>
+          </a:prstGeom>
+          <a:noFill/>
+        </p:spPr>
+        <p:txBody>
+          <a:bodyPr wrap="square" lIns="45720" rIns="45720" tIns="27432" bIns="27432" anchor="t">
+            <a:spAutoFit/>
+          </a:bodyPr>
+          <a:lstStyle/>
+          <a:p>
+            <a:pPr algn="l">
+              <a:lnSpc>
+                <a:spcPct val="105000"/>
+              </a:lnSpc>
+            </a:pPr>
+            <a:r>
               <a:rPr sz="3800" b="1" i="0">
                 <a:solidFill>
                   <a:srgbClr val="F2F4F8"/>
                 </a:solidFill>
                 <a:latin typeface="Inter"/>
               </a:rPr>
+              <a:t>The player.</a:t>
+            </a:r>
+          </a:p>
+          <a:p>
+            <a:pPr algn="l">
+              <a:lnSpc>
+                <a:spcPct val="105000"/>
+              </a:lnSpc>
+            </a:pPr>
+            <a:r>
+              <a:rPr sz="3800" b="1" i="0">
+                <a:solidFill>
+                  <a:srgbClr val="F2F4F8"/>
+                </a:solidFill>
+                <a:latin typeface="Inter"/>
+              </a:rPr>
               <a:t>Next game: </a:t>
             </a:r>
             <a:r>
@@ -13624,7 +13871,7 @@
       </p:sp>
       <p:sp>
         <p:nvSpPr>
-          <p:cNvPr id="11" name="Oval 10"/>
+          <p:cNvPr id="15" name="Oval 14"/>
           <p:cNvSpPr/>
           <p:nvPr/>
         </p:nvSpPr>
@@ -13677,7 +13924,7 @@
       </p:sp>
       <p:sp>
         <p:nvSpPr>
-          <p:cNvPr id="12" name="TextBox 11"/>
+          <p:cNvPr id="16" name="TextBox 15"/>
           <p:cNvSpPr txBox="1"/>
           <p:nvPr/>
         </p:nvSpPr>
@@ -13725,7 +13972,7 @@
       </p:sp>
       <p:sp>
         <p:nvSpPr>
-          <p:cNvPr id="13" name="Oval 12"/>
+          <p:cNvPr id="17" name="Oval 16"/>
           <p:cNvSpPr/>
           <p:nvPr/>
         </p:nvSpPr>
@@ -13778,7 +14025,7 @@
       </p:sp>
       <p:sp>
         <p:nvSpPr>
-          <p:cNvPr id="14" name="TextBox 13"/>
+          <p:cNvPr id="18" name="TextBox 17"/>
           <p:cNvSpPr txBox="1"/>
           <p:nvPr/>
         </p:nvSpPr>
@@ -13817,7 +14064,7 @@
       </p:sp>
       <p:sp>
         <p:nvSpPr>
-          <p:cNvPr id="15" name="Oval 14"/>
+          <p:cNvPr id="19" name="Oval 18"/>
           <p:cNvSpPr/>
           <p:nvPr/>
         </p:nvSpPr>
@@ -13870,7 +14117,7 @@
       </p:sp>
       <p:sp>
         <p:nvSpPr>
-          <p:cNvPr id="16" name="TextBox 15"/>
+          <p:cNvPr id="20" name="TextBox 19"/>
           <p:cNvSpPr txBox="1"/>
           <p:nvPr/>
         </p:nvSpPr>
@@ -13909,7 +14156,7 @@
       </p:sp>
       <p:sp>
         <p:nvSpPr>
-          <p:cNvPr id="17" name="TextBox 16"/>
+          <p:cNvPr id="21" name="TextBox 20"/>
           <p:cNvSpPr txBox="1"/>
           <p:nvPr/>
         </p:nvSpPr>

</xml_diff>